<commit_message>
AHTH graph generator software for update to github - Ver. 2.1
DETAILS : Revised send the data to fast and display web.

CREATE : [GITHUB] [apiwat.kamsiri] [Release] [01h 00m]
</commit_message>
<xml_diff>
--- a/docs/AHTH-Graph-Generator-Training.pptx
+++ b/docs/AHTH-Graph-Generator-Training.pptx
@@ -5281,7 +5281,7 @@
                 <a:ea typeface="Leelawadee UI"/>
                 <a:cs typeface="Leelawadee UI"/>
               </a:rPr>
-              <a:t>Release 2.0 · https://ahth-graph-generator.github.io</a:t>
+              <a:t>Release 2.1 · https://ahth-graph-generator.github.io</a:t>
             </a:r>
           </a:p>
         </p:txBody>
@@ -22151,7 +22151,7 @@
                 <a:ea typeface="Leelawadee UI"/>
                 <a:cs typeface="Leelawadee UI"/>
               </a:rPr>
-              <a:t>git commit -m "Release 2.0: …"</a:t>
+              <a:t>git commit -m "Release 2.1: …"</a:t>
             </a:r>
           </a:p>
         </p:txBody>

</xml_diff>

<commit_message>
AHTH graph generator software for update to github - Ver. 2.2
DETAILS : Update web script for loading the data to fast.

CREATE : [GITHUB] [apiwat.kamsiri] [Release] [01h 00m]
</commit_message>
<xml_diff>
--- a/docs/AHTH-Graph-Generator-Training.pptx
+++ b/docs/AHTH-Graph-Generator-Training.pptx
@@ -5281,7 +5281,7 @@
                 <a:ea typeface="Leelawadee UI"/>
                 <a:cs typeface="Leelawadee UI"/>
               </a:rPr>
-              <a:t>Release 2.1 · https://ahth-graph-generator.github.io</a:t>
+              <a:t>Release 2.2 · https://ahth-graph-generator.github.io</a:t>
             </a:r>
           </a:p>
         </p:txBody>
@@ -22151,7 +22151,7 @@
                 <a:ea typeface="Leelawadee UI"/>
                 <a:cs typeface="Leelawadee UI"/>
               </a:rPr>
-              <a:t>git commit -m "Release 2.1: …"</a:t>
+              <a:t>git commit -m "Release 2.2: …"</a:t>
             </a:r>
           </a:p>
         </p:txBody>

</xml_diff>

<commit_message>
AHTH graph generator software for update to github - Ver. 2.3
DETAILS : Update graph details to show.

CREATE : [GITHUB] [apiwat.kamsiri] [Release] [01h 00m]
</commit_message>
<xml_diff>
--- a/docs/AHTH-Graph-Generator-Training.pptx
+++ b/docs/AHTH-Graph-Generator-Training.pptx
@@ -5281,7 +5281,7 @@
                 <a:ea typeface="Leelawadee UI"/>
                 <a:cs typeface="Leelawadee UI"/>
               </a:rPr>
-              <a:t>Release 2.2 · https://ahth-graph-generator.github.io</a:t>
+              <a:t>Release 2.3 · https://ahth-graph-generator.github.io</a:t>
             </a:r>
           </a:p>
         </p:txBody>
@@ -22151,7 +22151,7 @@
                 <a:ea typeface="Leelawadee UI"/>
                 <a:cs typeface="Leelawadee UI"/>
               </a:rPr>
-              <a:t>git commit -m "Release 2.2: …"</a:t>
+              <a:t>git commit -m "Release 2.3: …"</a:t>
             </a:r>
           </a:p>
         </p:txBody>

</xml_diff>

<commit_message>
AHTH graph generator software for update to github - Ver. 2.4
DETAILS : Update graph details to show (Door open time).

CREATE : [GITHUB] [apiwat.kamsiri] [Release] [01h 00m]
</commit_message>
<xml_diff>
--- a/docs/AHTH-Graph-Generator-Training.pptx
+++ b/docs/AHTH-Graph-Generator-Training.pptx
@@ -5281,7 +5281,7 @@
                 <a:ea typeface="Leelawadee UI"/>
                 <a:cs typeface="Leelawadee UI"/>
               </a:rPr>
-              <a:t>Release 2.3 · https://ahth-graph-generator.github.io</a:t>
+              <a:t>Release 2.4 · https://ahth-graph-generator.github.io</a:t>
             </a:r>
           </a:p>
         </p:txBody>
@@ -22151,7 +22151,7 @@
                 <a:ea typeface="Leelawadee UI"/>
                 <a:cs typeface="Leelawadee UI"/>
               </a:rPr>
-              <a:t>git commit -m "Release 2.3: …"</a:t>
+              <a:t>git commit -m "Release 2.4: …"</a:t>
             </a:r>
           </a:p>
         </p:txBody>

</xml_diff>

<commit_message>
AHTH graph generator website for update to github - Ver. 2.5
- Update version to 2.5
- Upate symbol to show correct when sampling more that 1 min

GITHUB / Release / 01h 00m
Co-Authored-By: Owner <apiwat.kamsiri>
</commit_message>
<xml_diff>
--- a/docs/AHTH-Graph-Generator-Training.pptx
+++ b/docs/AHTH-Graph-Generator-Training.pptx
@@ -5281,7 +5281,7 @@
                 <a:ea typeface="Leelawadee UI"/>
                 <a:cs typeface="Leelawadee UI"/>
               </a:rPr>
-              <a:t>Release 2.4 · https://ahth-graph-generator.github.io</a:t>
+              <a:t>Release 2.5 · https://ahth-graph-generator.github.io</a:t>
             </a:r>
           </a:p>
         </p:txBody>
@@ -22151,7 +22151,7 @@
                 <a:ea typeface="Leelawadee UI"/>
                 <a:cs typeface="Leelawadee UI"/>
               </a:rPr>
-              <a:t>git commit -m "Release 2.4: …"</a:t>
+              <a:t>git commit -m "Release 2.5: …"</a:t>
             </a:r>
           </a:p>
         </p:txBody>

</xml_diff>

<commit_message>
AHTH graph generator website for update to github - Ver. 2.6
- Update version to 2.6
- The "Door open time" includes a total duration in minutes, shown in parentheses and aligned to the right; the "Reset" row, following a power outage, indicates that the power has been turned back ON.
- A power reset is treated as a power outage; all connections are interrupted during that interval.

GITHUB / Release / 01h 00m
Co-Authored-By: Owner <apiwat.kamsiri>
</commit_message>
<xml_diff>
--- a/docs/AHTH-Graph-Generator-Training.pptx
+++ b/docs/AHTH-Graph-Generator-Training.pptx
@@ -5281,7 +5281,7 @@
                 <a:ea typeface="Leelawadee UI"/>
                 <a:cs typeface="Leelawadee UI"/>
               </a:rPr>
-              <a:t>Release 2.5 · https://ahth-graph-generator.github.io</a:t>
+              <a:t>Release 2.6 · https://ahth-graph-generator.github.io</a:t>
             </a:r>
           </a:p>
         </p:txBody>
@@ -22151,7 +22151,7 @@
                 <a:ea typeface="Leelawadee UI"/>
                 <a:cs typeface="Leelawadee UI"/>
               </a:rPr>
-              <a:t>git commit -m "Release 2.5: …"</a:t>
+              <a:t>git commit -m "Release 2.6: …"</a:t>
             </a:r>
           </a:p>
         </p:txBody>

</xml_diff>